<commit_message>
add four NTC sensors
</commit_message>
<xml_diff>
--- a/005_ProjectRTOS/ESP32CCode/Component/esp32.pptx
+++ b/005_ProjectRTOS/ESP32CCode/Component/esp32.pptx
@@ -3486,8 +3486,8 @@
         </p:blipFill>
         <p:spPr>
           <a:xfrm>
-            <a:off x="1706499" y="2781988"/>
-            <a:ext cx="8779001" cy="2438611"/>
+            <a:off x="838200" y="2007288"/>
+            <a:ext cx="10444545" cy="2901262"/>
           </a:xfrm>
           <a:prstGeom prst="rect">
             <a:avLst/>

</xml_diff>

<commit_message>
add the four relays and activate the heater model, clean the old sensors
</commit_message>
<xml_diff>
--- a/005_ProjectRTOS/ESP32CCode/Component/esp32.pptx
+++ b/005_ProjectRTOS/ESP32CCode/Component/esp32.pptx
@@ -3732,8 +3732,8 @@
         </p:blipFill>
         <p:spPr>
           <a:xfrm>
-            <a:off x="728776" y="1112329"/>
-            <a:ext cx="4701947" cy="4404742"/>
+            <a:off x="430326" y="642428"/>
+            <a:ext cx="5645305" cy="5288471"/>
           </a:xfrm>
           <a:prstGeom prst="rect">
             <a:avLst/>
@@ -3762,8 +3762,8 @@
         </p:blipFill>
         <p:spPr>
           <a:xfrm>
-            <a:off x="6472988" y="1001829"/>
-            <a:ext cx="4656223" cy="4625741"/>
+            <a:off x="6390438" y="468429"/>
+            <a:ext cx="5498466" cy="5462470"/>
           </a:xfrm>
           <a:prstGeom prst="rect">
             <a:avLst/>

</xml_diff>